<commit_message>
Update Guia + WP
</commit_message>
<xml_diff>
--- a/Guía para editar la web del grupo.pptx
+++ b/Guía para editar la web del grupo.pptx
@@ -3859,6 +3859,36 @@
           </a:p>
         </p:txBody>
       </p:sp>
+      <p:pic>
+        <p:nvPicPr>
+          <p:cNvPr id="6" name="Imagen 5">
+            <a:extLst>
+              <a:ext uri="{FF2B5EF4-FFF2-40B4-BE49-F238E27FC236}">
+                <a16:creationId xmlns:a16="http://schemas.microsoft.com/office/drawing/2014/main" id="{20D4DF71-8FC8-C8C9-FCE3-06A91669BB32}"/>
+              </a:ext>
+            </a:extLst>
+          </p:cNvPr>
+          <p:cNvPicPr>
+            <a:picLocks noChangeAspect="1"/>
+          </p:cNvPicPr>
+          <p:nvPr/>
+        </p:nvPicPr>
+        <p:blipFill>
+          <a:blip r:embed="rId5"/>
+          <a:stretch>
+            <a:fillRect/>
+          </a:stretch>
+        </p:blipFill>
+        <p:spPr>
+          <a:xfrm>
+            <a:off x="812659" y="5184784"/>
+            <a:ext cx="2146852" cy="265512"/>
+          </a:xfrm>
+          <a:prstGeom prst="rect">
+            <a:avLst/>
+          </a:prstGeom>
+        </p:spPr>
+      </p:pic>
     </p:spTree>
     <p:extLst>
       <p:ext uri="{BB962C8B-B14F-4D97-AF65-F5344CB8AC3E}">
@@ -4141,7 +4171,7 @@
               <a:rPr lang="es-ES" dirty="0">
                 <a:latin typeface="Consolas" panose="020B0609020204030204" pitchFamily="49" charset="0"/>
               </a:rPr>
-              <a:t>imagine_WP.zip</a:t>
+              <a:t>imagine.zip</a:t>
             </a:r>
           </a:p>
         </p:txBody>
@@ -7938,8 +7968,8 @@
         </p:nvSpPr>
         <p:spPr>
           <a:xfrm>
-            <a:off x="6400799" y="1757185"/>
-            <a:ext cx="5664115" cy="369332"/>
+            <a:off x="6320072" y="1754870"/>
+            <a:ext cx="5871928" cy="369332"/>
           </a:xfrm>
           <a:prstGeom prst="rect">
             <a:avLst/>
@@ -7953,11 +7983,18 @@
           <a:lstStyle/>
           <a:p>
             <a:r>
-              <a:rPr lang="es-ES" dirty="0"/>
+              <a:rPr lang="es-ES" b="1" u="sng" dirty="0">
+                <a:solidFill>
+                  <a:srgbClr val="FF0000"/>
+                </a:solidFill>
+              </a:rPr>
               <a:t>Los agrupamos todos en una carpeta llamada </a:t>
             </a:r>
             <a:r>
-              <a:rPr lang="es-ES" dirty="0">
+              <a:rPr lang="es-ES" b="1" u="sng" dirty="0">
+                <a:solidFill>
+                  <a:srgbClr val="FF0000"/>
+                </a:solidFill>
                 <a:latin typeface="Consolas" panose="020B0609020204030204" pitchFamily="49" charset="0"/>
               </a:rPr>
               <a:t>imagine</a:t>
@@ -8176,7 +8213,7 @@
               <a:rPr lang="es-ES" dirty="0">
                 <a:latin typeface="Consolas" panose="020B0609020204030204" pitchFamily="49" charset="0"/>
               </a:rPr>
-              <a:t>imagine_WP.zip</a:t>
+              <a:t>imagine.zip</a:t>
             </a:r>
           </a:p>
         </p:txBody>
@@ -8271,58 +8308,6 @@
         <p:spPr>
           <a:xfrm>
             <a:off x="5732206" y="4866968"/>
-            <a:ext cx="560439" cy="304800"/>
-          </a:xfrm>
-          <a:prstGeom prst="ellipse">
-            <a:avLst/>
-          </a:prstGeom>
-          <a:noFill/>
-          <a:ln>
-            <a:solidFill>
-              <a:srgbClr val="FF0000"/>
-            </a:solidFill>
-          </a:ln>
-        </p:spPr>
-        <p:style>
-          <a:lnRef idx="2">
-            <a:schemeClr val="accent1">
-              <a:shade val="15000"/>
-            </a:schemeClr>
-          </a:lnRef>
-          <a:fillRef idx="1">
-            <a:schemeClr val="accent1"/>
-          </a:fillRef>
-          <a:effectRef idx="0">
-            <a:schemeClr val="accent1"/>
-          </a:effectRef>
-          <a:fontRef idx="minor">
-            <a:schemeClr val="lt1"/>
-          </a:fontRef>
-        </p:style>
-        <p:txBody>
-          <a:bodyPr rtlCol="0" anchor="ctr"/>
-          <a:lstStyle/>
-          <a:p>
-            <a:pPr algn="ctr"/>
-            <a:endParaRPr lang="es-ES"/>
-          </a:p>
-        </p:txBody>
-      </p:sp>
-      <p:sp>
-        <p:nvSpPr>
-          <p:cNvPr id="34" name="Elipse 33">
-            <a:extLst>
-              <a:ext uri="{FF2B5EF4-FFF2-40B4-BE49-F238E27FC236}">
-                <a16:creationId xmlns:a16="http://schemas.microsoft.com/office/drawing/2014/main" id="{282420C5-B899-9BB4-DE4E-06F5299AFA9B}"/>
-              </a:ext>
-            </a:extLst>
-          </p:cNvPr>
-          <p:cNvSpPr/>
-          <p:nvPr/>
-        </p:nvSpPr>
-        <p:spPr>
-          <a:xfrm>
-            <a:off x="4989868" y="4178418"/>
             <a:ext cx="560439" cy="304800"/>
           </a:xfrm>
           <a:prstGeom prst="ellipse">
@@ -8763,6 +8748,88 @@
               </a:rPr>
               <a:t>SOLO ESTOS 4 ARCHIVOS</a:t>
             </a:r>
+          </a:p>
+        </p:txBody>
+      </p:sp>
+      <p:pic>
+        <p:nvPicPr>
+          <p:cNvPr id="11" name="Imagen 10">
+            <a:extLst>
+              <a:ext uri="{FF2B5EF4-FFF2-40B4-BE49-F238E27FC236}">
+                <a16:creationId xmlns:a16="http://schemas.microsoft.com/office/drawing/2014/main" id="{66B22C0E-E7B7-7A22-F57D-C3939685C3C5}"/>
+              </a:ext>
+            </a:extLst>
+          </p:cNvPr>
+          <p:cNvPicPr>
+            <a:picLocks noChangeAspect="1"/>
+          </p:cNvPicPr>
+          <p:nvPr/>
+        </p:nvPicPr>
+        <p:blipFill>
+          <a:blip r:embed="rId5"/>
+          <a:stretch>
+            <a:fillRect/>
+          </a:stretch>
+        </p:blipFill>
+        <p:spPr>
+          <a:xfrm>
+            <a:off x="4989868" y="4244810"/>
+            <a:ext cx="621466" cy="193078"/>
+          </a:xfrm>
+          <a:prstGeom prst="rect">
+            <a:avLst/>
+          </a:prstGeom>
+        </p:spPr>
+      </p:pic>
+      <p:sp>
+        <p:nvSpPr>
+          <p:cNvPr id="34" name="Elipse 33">
+            <a:extLst>
+              <a:ext uri="{FF2B5EF4-FFF2-40B4-BE49-F238E27FC236}">
+                <a16:creationId xmlns:a16="http://schemas.microsoft.com/office/drawing/2014/main" id="{282420C5-B899-9BB4-DE4E-06F5299AFA9B}"/>
+              </a:ext>
+            </a:extLst>
+          </p:cNvPr>
+          <p:cNvSpPr/>
+          <p:nvPr/>
+        </p:nvSpPr>
+        <p:spPr>
+          <a:xfrm>
+            <a:off x="4989868" y="4178418"/>
+            <a:ext cx="560439" cy="304800"/>
+          </a:xfrm>
+          <a:prstGeom prst="ellipse">
+            <a:avLst/>
+          </a:prstGeom>
+          <a:noFill/>
+          <a:ln>
+            <a:solidFill>
+              <a:srgbClr val="FF0000"/>
+            </a:solidFill>
+          </a:ln>
+        </p:spPr>
+        <p:style>
+          <a:lnRef idx="2">
+            <a:schemeClr val="accent1">
+              <a:shade val="15000"/>
+            </a:schemeClr>
+          </a:lnRef>
+          <a:fillRef idx="1">
+            <a:schemeClr val="accent1"/>
+          </a:fillRef>
+          <a:effectRef idx="0">
+            <a:schemeClr val="accent1"/>
+          </a:effectRef>
+          <a:fontRef idx="minor">
+            <a:schemeClr val="lt1"/>
+          </a:fontRef>
+        </p:style>
+        <p:txBody>
+          <a:bodyPr rtlCol="0" anchor="ctr"/>
+          <a:lstStyle/>
+          <a:p>
+            <a:pPr algn="ctr"/>
+            <a:endParaRPr lang="es-ES"/>
           </a:p>
         </p:txBody>
       </p:sp>
@@ -9385,7 +9452,7 @@
               <a:rPr lang="en-US" b="1" dirty="0">
                 <a:latin typeface="Consolas" panose="020B0609020204030204" pitchFamily="49" charset="0"/>
               </a:rPr>
-              <a:t> --mirror --convert-links --adjust-extension --page-requisites --no-parent -P "C:\Users\nicoc\Desktop\GitHub\imagine-uo.github.io" http://imagine-wp.local/</a:t>
+              <a:t> --mirror --convert-links --adjust-extension --page-requisites --no-parent -P "C:\Users\nicoc\Desktop\GitHub\imagine-uo.github.io" http://imagine.local/</a:t>
             </a:r>
             <a:endParaRPr lang="es-ES" b="1" dirty="0">
               <a:latin typeface="Consolas" panose="020B0609020204030204" pitchFamily="49" charset="0"/>
@@ -9596,16 +9663,10 @@
               <a:t>SEGUNDO: Tarda un poco (bastante poco) y descarga en el directorio indicado una carpeta llamada </a:t>
             </a:r>
             <a:r>
-              <a:rPr lang="es-ES" sz="2000" dirty="0">
-                <a:latin typeface="Consolas" panose="020B0609020204030204" pitchFamily="49" charset="0"/>
-              </a:rPr>
-              <a:t>imagine-</a:t>
-            </a:r>
-            <a:r>
               <a:rPr lang="es-ES" sz="2000" dirty="0" err="1">
                 <a:latin typeface="Consolas" panose="020B0609020204030204" pitchFamily="49" charset="0"/>
               </a:rPr>
-              <a:t>wp.local</a:t>
+              <a:t>imagine.local</a:t>
             </a:r>
             <a:r>
               <a:rPr lang="es-ES" sz="2000" dirty="0"/>
@@ -9771,6 +9832,36 @@
           </a:prstGeom>
         </p:spPr>
       </p:pic>
+      <p:pic>
+        <p:nvPicPr>
+          <p:cNvPr id="5" name="Imagen 4">
+            <a:extLst>
+              <a:ext uri="{FF2B5EF4-FFF2-40B4-BE49-F238E27FC236}">
+                <a16:creationId xmlns:a16="http://schemas.microsoft.com/office/drawing/2014/main" id="{4316C7ED-585D-3ED1-152C-AFDA4CFB3E13}"/>
+              </a:ext>
+            </a:extLst>
+          </p:cNvPr>
+          <p:cNvPicPr>
+            <a:picLocks noChangeAspect="1"/>
+          </p:cNvPicPr>
+          <p:nvPr/>
+        </p:nvPicPr>
+        <p:blipFill>
+          <a:blip r:embed="rId3"/>
+          <a:stretch>
+            <a:fillRect/>
+          </a:stretch>
+        </p:blipFill>
+        <p:spPr>
+          <a:xfrm>
+            <a:off x="6027174" y="3824501"/>
+            <a:ext cx="2177822" cy="322640"/>
+          </a:xfrm>
+          <a:prstGeom prst="rect">
+            <a:avLst/>
+          </a:prstGeom>
+        </p:spPr>
+      </p:pic>
     </p:spTree>
     <p:extLst>
       <p:ext uri="{BB962C8B-B14F-4D97-AF65-F5344CB8AC3E}">
@@ -9978,7 +10069,7 @@
         </p:blipFill>
         <p:spPr>
           <a:xfrm>
-            <a:off x="5588764" y="4879532"/>
+            <a:off x="5598596" y="4879532"/>
             <a:ext cx="3191444" cy="1880523"/>
           </a:xfrm>
           <a:prstGeom prst="rect">
@@ -10030,6 +10121,36 @@
           </a:fontRef>
         </p:style>
       </p:cxnSp>
+      <p:pic>
+        <p:nvPicPr>
+          <p:cNvPr id="6" name="Imagen 5">
+            <a:extLst>
+              <a:ext uri="{FF2B5EF4-FFF2-40B4-BE49-F238E27FC236}">
+                <a16:creationId xmlns:a16="http://schemas.microsoft.com/office/drawing/2014/main" id="{C97B56A6-8211-952A-52DB-19A9DD6D1698}"/>
+              </a:ext>
+            </a:extLst>
+          </p:cNvPr>
+          <p:cNvPicPr>
+            <a:picLocks noChangeAspect="1"/>
+          </p:cNvPicPr>
+          <p:nvPr/>
+        </p:nvPicPr>
+        <p:blipFill>
+          <a:blip r:embed="rId3"/>
+          <a:stretch>
+            <a:fillRect/>
+          </a:stretch>
+        </p:blipFill>
+        <p:spPr>
+          <a:xfrm>
+            <a:off x="5828222" y="5770264"/>
+            <a:ext cx="848557" cy="125712"/>
+          </a:xfrm>
+          <a:prstGeom prst="rect">
+            <a:avLst/>
+          </a:prstGeom>
+        </p:spPr>
+      </p:pic>
     </p:spTree>
     <p:extLst>
       <p:ext uri="{BB962C8B-B14F-4D97-AF65-F5344CB8AC3E}">
@@ -12030,10 +12151,10 @@
       </p:grpSpPr>
       <p:pic>
         <p:nvPicPr>
-          <p:cNvPr id="5" name="Imagen 4">
-            <a:extLst>
-              <a:ext uri="{FF2B5EF4-FFF2-40B4-BE49-F238E27FC236}">
-                <a16:creationId xmlns:a16="http://schemas.microsoft.com/office/drawing/2014/main" id="{22154DF6-C82D-D801-499F-176BBA9357E2}"/>
+          <p:cNvPr id="6" name="Imagen 5" descr="Interfaz de usuario gráfica, Texto&#10;&#10;El contenido generado por IA puede ser incorrecto.">
+            <a:extLst>
+              <a:ext uri="{FF2B5EF4-FFF2-40B4-BE49-F238E27FC236}">
+                <a16:creationId xmlns:a16="http://schemas.microsoft.com/office/drawing/2014/main" id="{C5627E9A-2959-7596-B88B-BEFBC1BB774F}"/>
               </a:ext>
             </a:extLst>
           </p:cNvPr>
@@ -12050,8 +12171,8 @@
         </p:blipFill>
         <p:spPr>
           <a:xfrm>
-            <a:off x="4712027" y="1999360"/>
-            <a:ext cx="6846761" cy="1989657"/>
+            <a:off x="4564206" y="1978800"/>
+            <a:ext cx="7411484" cy="1981477"/>
           </a:xfrm>
           <a:prstGeom prst="rect">
             <a:avLst/>
@@ -12133,16 +12254,10 @@
           </a:p>
           <a:p>
             <a:r>
-              <a:rPr lang="es-ES" dirty="0" err="1">
-                <a:latin typeface="Consolas" panose="020B0609020204030204" pitchFamily="49" charset="0"/>
-              </a:rPr>
-              <a:t>imagine_WP</a:t>
-            </a:r>
-            <a:r>
               <a:rPr lang="es-ES" dirty="0">
                 <a:latin typeface="Consolas" panose="020B0609020204030204" pitchFamily="49" charset="0"/>
               </a:rPr>
-              <a:t> </a:t>
+              <a:t>imagine </a:t>
             </a:r>
             <a:r>
               <a:rPr lang="es-ES" dirty="0"/>

</xml_diff>